<commit_message>
fix: replace unrealistic hallucination metric with 100% evidence-linked citations
</commit_message>
<xml_diff>
--- a/MediKiosk_Round1_Presentation.pptx
+++ b/MediKiosk_Round1_Presentation.pptx
@@ -736,7 +736,7 @@
           </a:p>
           <a:p>
             <a:r>
-              <a:t>Judges often question whether AI can be trusted in medical environments. Our answer is absolute safety guardrails. First, emergency red-flags do not rely on LLMs; they are hardcoded deterministic rules. Second, our copilot enforces a 0.0% unsupported claim rate: every claim must have a clickable link back to an answer or prescription box. Third, we natively support both Allopathic and AYUSH clinical models.</a:t>
+              <a:t>Judges often question whether AI can be trusted in medical environments. Our answer is absolute safety guardrails. First, emergency red-flags do not rely on LLMs; they are hardcoded deterministic rules. Second, our copilot enforces strict evidence citations: every claim has a clickable link back to an answer or prescription box, leaving the doctor in full audit control. Third, we natively support both Allopathic and AYUSH clinical models.</a:t>
             </a:r>
           </a:p>
         </p:txBody>
@@ -5550,7 +5550,7 @@
               </a:defRPr>
             </a:pPr>
             <a:r>
-              <a:t>🛡️ 0.0% Hallucination: Evidence Source Chips</a:t>
+              <a:t>🛡️ Traceable Evidence Source Citations</a:t>
             </a:r>
           </a:p>
           <a:p>
@@ -5565,7 +5565,7 @@
               </a:defRPr>
             </a:pPr>
             <a:r>
-              <a:t>Every single statement generated by the clinical AI copilot contains clickable citation chips ([Answer #12], [Doc #03]). The physician can click to verify against raw voice transcripts or scanned document images. Any ungrounded claim is deterministically blocked.</a:t>
+              <a:t>Every clinical statement generated by the AI copilot contains clickable citation chips ([Answer #12], [Doc #03]). The physician can click to trace back directly to raw voice transcripts or scanned prescription images, ensuring strict ground-truth auditability.</a:t>
             </a:r>
           </a:p>
         </p:txBody>

</xml_diff>